<commit_message>
Added Ed's video at end.
</commit_message>
<xml_diff>
--- a/SENIOR-CENTER-CYBERSEC-PRESENTATION-2026-1020.pptx
+++ b/SENIOR-CENTER-CYBERSEC-PRESENTATION-2026-1020.pptx
@@ -360,7 +360,7 @@
             <a:fld id="{B61BEF0D-F0BB-DE4B-95CE-6DB70DBA9567}" type="datetimeFigureOut">
               <a:rPr lang="en-US" dirty="0"/>
               <a:pPr/>
-              <a:t>10/24/2026</a:t>
+              <a:t>10/28/2026</a:t>
             </a:fld>
             <a:endParaRPr lang="en-US" dirty="0"/>
           </a:p>
@@ -773,7 +773,7 @@
             <a:fld id="{B61BEF0D-F0BB-DE4B-95CE-6DB70DBA9567}" type="datetimeFigureOut">
               <a:rPr lang="en-US" dirty="0"/>
               <a:pPr/>
-              <a:t>10/24/2026</a:t>
+              <a:t>10/28/2026</a:t>
             </a:fld>
             <a:endParaRPr lang="en-US" dirty="0"/>
           </a:p>
@@ -1048,7 +1048,7 @@
             <a:fld id="{B61BEF0D-F0BB-DE4B-95CE-6DB70DBA9567}" type="datetimeFigureOut">
               <a:rPr lang="en-US" dirty="0"/>
               <a:pPr/>
-              <a:t>10/24/2026</a:t>
+              <a:t>10/28/2026</a:t>
             </a:fld>
             <a:endParaRPr lang="en-US" dirty="0"/>
           </a:p>
@@ -1613,7 +1613,7 @@
             <a:fld id="{B61BEF0D-F0BB-DE4B-95CE-6DB70DBA9567}" type="datetimeFigureOut">
               <a:rPr lang="en-US" dirty="0"/>
               <a:pPr/>
-              <a:t>10/24/2026</a:t>
+              <a:t>10/28/2026</a:t>
             </a:fld>
             <a:endParaRPr lang="en-US" dirty="0"/>
           </a:p>
@@ -1888,7 +1888,7 @@
             <a:fld id="{B61BEF0D-F0BB-DE4B-95CE-6DB70DBA9567}" type="datetimeFigureOut">
               <a:rPr lang="en-US" dirty="0"/>
               <a:pPr/>
-              <a:t>10/24/2026</a:t>
+              <a:t>10/28/2026</a:t>
             </a:fld>
             <a:endParaRPr lang="en-US" dirty="0"/>
           </a:p>
@@ -2447,7 +2447,7 @@
             <a:fld id="{B61BEF0D-F0BB-DE4B-95CE-6DB70DBA9567}" type="datetimeFigureOut">
               <a:rPr lang="en-US" dirty="0"/>
               <a:pPr/>
-              <a:t>10/24/2026</a:t>
+              <a:t>10/28/2026</a:t>
             </a:fld>
             <a:endParaRPr lang="en-US" dirty="0"/>
           </a:p>
@@ -2771,7 +2771,7 @@
             <a:fld id="{B61BEF0D-F0BB-DE4B-95CE-6DB70DBA9567}" type="datetimeFigureOut">
               <a:rPr lang="en-US" dirty="0"/>
               <a:pPr/>
-              <a:t>10/24/2026</a:t>
+              <a:t>10/28/2026</a:t>
             </a:fld>
             <a:endParaRPr lang="en-US" dirty="0"/>
           </a:p>
@@ -2945,7 +2945,7 @@
             <a:fld id="{B61BEF0D-F0BB-DE4B-95CE-6DB70DBA9567}" type="datetimeFigureOut">
               <a:rPr lang="en-US" dirty="0"/>
               <a:pPr/>
-              <a:t>10/24/2026</a:t>
+              <a:t>10/28/2026</a:t>
             </a:fld>
             <a:endParaRPr lang="en-US" dirty="0"/>
           </a:p>
@@ -3180,7 +3180,7 @@
             <a:fld id="{B61BEF0D-F0BB-DE4B-95CE-6DB70DBA9567}" type="datetimeFigureOut">
               <a:rPr lang="en-US" dirty="0"/>
               <a:pPr/>
-              <a:t>10/24/2026</a:t>
+              <a:t>10/28/2026</a:t>
             </a:fld>
             <a:endParaRPr lang="en-US" dirty="0"/>
           </a:p>
@@ -3377,7 +3377,7 @@
             <a:fld id="{B61BEF0D-F0BB-DE4B-95CE-6DB70DBA9567}" type="datetimeFigureOut">
               <a:rPr lang="en-US" dirty="0"/>
               <a:pPr/>
-              <a:t>10/24/2026</a:t>
+              <a:t>10/28/2026</a:t>
             </a:fld>
             <a:endParaRPr lang="en-US" dirty="0"/>
           </a:p>
@@ -3650,7 +3650,7 @@
             <a:fld id="{B61BEF0D-F0BB-DE4B-95CE-6DB70DBA9567}" type="datetimeFigureOut">
               <a:rPr lang="en-US" dirty="0"/>
               <a:pPr/>
-              <a:t>10/24/2026</a:t>
+              <a:t>10/28/2026</a:t>
             </a:fld>
             <a:endParaRPr lang="en-US" dirty="0"/>
           </a:p>
@@ -3913,7 +3913,7 @@
             <a:fld id="{B61BEF0D-F0BB-DE4B-95CE-6DB70DBA9567}" type="datetimeFigureOut">
               <a:rPr lang="en-US" dirty="0"/>
               <a:pPr/>
-              <a:t>10/24/2026</a:t>
+              <a:t>10/28/2026</a:t>
             </a:fld>
             <a:endParaRPr lang="en-US" dirty="0"/>
           </a:p>
@@ -4284,7 +4284,7 @@
             <a:fld id="{B61BEF0D-F0BB-DE4B-95CE-6DB70DBA9567}" type="datetimeFigureOut">
               <a:rPr lang="en-US" dirty="0"/>
               <a:pPr/>
-              <a:t>10/24/2026</a:t>
+              <a:t>10/28/2026</a:t>
             </a:fld>
             <a:endParaRPr lang="en-US" dirty="0"/>
           </a:p>
@@ -4429,7 +4429,7 @@
             <a:fld id="{B61BEF0D-F0BB-DE4B-95CE-6DB70DBA9567}" type="datetimeFigureOut">
               <a:rPr lang="en-US" dirty="0"/>
               <a:pPr/>
-              <a:t>10/24/2026</a:t>
+              <a:t>10/28/2026</a:t>
             </a:fld>
             <a:endParaRPr lang="en-US" dirty="0"/>
           </a:p>
@@ -4551,7 +4551,7 @@
             <a:fld id="{B61BEF0D-F0BB-DE4B-95CE-6DB70DBA9567}" type="datetimeFigureOut">
               <a:rPr lang="en-US" dirty="0"/>
               <a:pPr/>
-              <a:t>10/24/2026</a:t>
+              <a:t>10/28/2026</a:t>
             </a:fld>
             <a:endParaRPr lang="en-US" dirty="0"/>
           </a:p>
@@ -4833,7 +4833,7 @@
             <a:fld id="{B61BEF0D-F0BB-DE4B-95CE-6DB70DBA9567}" type="datetimeFigureOut">
               <a:rPr lang="en-US" dirty="0"/>
               <a:pPr/>
-              <a:t>10/24/2026</a:t>
+              <a:t>10/28/2026</a:t>
             </a:fld>
             <a:endParaRPr lang="en-US" dirty="0"/>
           </a:p>
@@ -5154,7 +5154,7 @@
             <a:fld id="{B61BEF0D-F0BB-DE4B-95CE-6DB70DBA9567}" type="datetimeFigureOut">
               <a:rPr lang="en-US" dirty="0"/>
               <a:pPr/>
-              <a:t>10/24/2026</a:t>
+              <a:t>10/28/2026</a:t>
             </a:fld>
             <a:endParaRPr lang="en-US" dirty="0"/>
           </a:p>
@@ -5365,7 +5365,7 @@
             <a:fld id="{B61BEF0D-F0BB-DE4B-95CE-6DB70DBA9567}" type="datetimeFigureOut">
               <a:rPr lang="en-US" dirty="0"/>
               <a:pPr/>
-              <a:t>10/24/2026</a:t>
+              <a:t>10/28/2026</a:t>
             </a:fld>
             <a:endParaRPr lang="en-US" dirty="0"/>
           </a:p>
@@ -7435,6 +7435,82 @@
           </a:p>
         </p:txBody>
       </p:sp>
+      <p:sp>
+        <p:nvSpPr>
+          <p:cNvPr id="3" name="TextBox 2">
+            <a:extLst>
+              <a:ext uri="{FF2B5EF4-FFF2-40B4-BE49-F238E27FC236}">
+                <a16:creationId xmlns:a16="http://schemas.microsoft.com/office/drawing/2014/main" id="{E5478224-6DEE-77E6-F616-E1276A93D898}"/>
+              </a:ext>
+            </a:extLst>
+          </p:cNvPr>
+          <p:cNvSpPr txBox="1"/>
+          <p:nvPr/>
+        </p:nvSpPr>
+        <p:spPr>
+          <a:xfrm>
+            <a:off x="1111624" y="4249271"/>
+            <a:ext cx="4837991" cy="369332"/>
+          </a:xfrm>
+          <a:prstGeom prst="rect">
+            <a:avLst/>
+          </a:prstGeom>
+          <a:noFill/>
+        </p:spPr>
+        <p:txBody>
+          <a:bodyPr wrap="none" rtlCol="0">
+            <a:spAutoFit/>
+          </a:bodyPr>
+          <a:lstStyle/>
+          <a:p>
+            <a:r>
+              <a:rPr lang="en-US" dirty="0">
+                <a:hlinkClick r:id="rId2"/>
+              </a:rPr>
+              <a:t>https://www.youtube.com/watch?v=y3iciE3qohk</a:t>
+            </a:r>
+            <a:r>
+              <a:rPr lang="en-US" dirty="0"/>
+              <a:t> </a:t>
+            </a:r>
+          </a:p>
+        </p:txBody>
+      </p:sp>
+      <p:sp>
+        <p:nvSpPr>
+          <p:cNvPr id="4" name="TextBox 3">
+            <a:extLst>
+              <a:ext uri="{FF2B5EF4-FFF2-40B4-BE49-F238E27FC236}">
+                <a16:creationId xmlns:a16="http://schemas.microsoft.com/office/drawing/2014/main" id="{8C7A23B2-B0E4-C238-4237-20358F818AE8}"/>
+              </a:ext>
+            </a:extLst>
+          </p:cNvPr>
+          <p:cNvSpPr txBox="1"/>
+          <p:nvPr/>
+        </p:nvSpPr>
+        <p:spPr>
+          <a:xfrm>
+            <a:off x="1093693" y="3881717"/>
+            <a:ext cx="4457118" cy="369332"/>
+          </a:xfrm>
+          <a:prstGeom prst="rect">
+            <a:avLst/>
+          </a:prstGeom>
+          <a:noFill/>
+        </p:spPr>
+        <p:txBody>
+          <a:bodyPr wrap="none" rtlCol="0">
+            <a:spAutoFit/>
+          </a:bodyPr>
+          <a:lstStyle/>
+          <a:p>
+            <a:r>
+              <a:rPr lang="en-US" dirty="0"/>
+              <a:t>One more short (4 minute) fun video to share</a:t>
+            </a:r>
+          </a:p>
+        </p:txBody>
+      </p:sp>
     </p:spTree>
     <p:extLst>
       <p:ext uri="{BB962C8B-B14F-4D97-AF65-F5344CB8AC3E}">

</xml_diff>